<commit_message>
Replace weather scale with faces and a thumbs-down
Judge feedback: children shouldn't have to translate a feeling into
weather before they can answer — the metaphor adds a step between the
question and the child. The scale is now four faces plus a thumbs-down
at the bottom.

The bottom is a thumbs-down rather than a crying face on the same
reasoning: a crying face is a big thing for a child to claim about
themselves, while a thumbs-down is unmistakable and low-stakes. Since a
gesture is not a face, every option sits in the same circular badge so
the row still reads as one scale.

Faces are inline SVG rather than emoji, so they render identically on
every school device. Palette stays warm-to-cool and never red — a low
day is not a failure.

The 1-5 scoring and all three detection rules are unchanged. The deck
now embeds the same artwork, rendered from the same paths.

Co-Authored-By: Claude Opus 4.8 <noreply@anthropic.com>
</commit_message>
<xml_diff>
--- a/Sunny-Pitch-Deck.pptx
+++ b/Sunny-Pitch-Deck.pptx
@@ -980,7 +980,7 @@
             <a:r>
               <a:rPr lang="en-US" dirty="0"/>
               <a:t>[0:40-1:05] The solution. Move fast here.
-"The child taps their weather. Five options, twenty seconds, once a day. No vocabulary needed — that matters enormously for neurodivergent kids."
+"The child taps a face. Five options, twenty seconds, once a day. No vocabulary needed — and no metaphor to decode first, which matters enormously for neurodivergent kids."
 "The teacher gets the class at a glance, plus soft signals. Never red alarms."
 Point at 'the child can see their own history' — it pre-empts the surveillance question.</a:t>
             </a:r>
@@ -1439,8 +1439,8 @@
             <a:r>
               <a:rPr lang="en-US" dirty="0"/>
               <a:t>[2:30-2:45] Inclusion. This is the slide that wins the EdTech track.
-"Ana is cloudy most days. She is never flagged — that's her normal, and normal is not a problem."
-"Ben is sunny most days. The same two rainy days get flagged, because for Ben they're a departure."
+"Ana checks in okay most days. She is never flagged — that's her normal, and normal is not a problem."
+"Ben checks in great most days. The same two not-good days get flagged, because for Ben they're a departure."
 "Change is the signal, not the level. That protects quiet and neurodivergent kids from being flagged for simply being themselves."
 If you only get one extra sentence in Q&amp;A, use this one.</a:t>
             </a:r>
@@ -2118,116 +2118,136 @@
           </a:p>
         </p:txBody>
       </p:sp>
-      <p:sp>
-        <p:nvSpPr>
-          <p:cNvPr id="8" name="Shape 6"/>
-          <p:cNvSpPr/>
-          <p:nvPr/>
-        </p:nvSpPr>
-        <p:spPr>
-          <a:xfrm>
-            <a:off x="868680" y="4892040"/>
-            <a:ext cx="402336" cy="402336"/>
-          </a:xfrm>
-          <a:prstGeom prst="ellipse">
-            <a:avLst/>
-          </a:prstGeom>
-          <a:solidFill>
-            <a:srgbClr val="FFCF4A"/>
-          </a:solidFill>
-          <a:ln/>
-        </p:spPr>
-      </p:sp>
-      <p:sp>
-        <p:nvSpPr>
-          <p:cNvPr id="9" name="Shape 7"/>
-          <p:cNvSpPr/>
-          <p:nvPr/>
-        </p:nvSpPr>
-        <p:spPr>
-          <a:xfrm>
-            <a:off x="1435608" y="4892040"/>
-            <a:ext cx="402336" cy="402336"/>
-          </a:xfrm>
-          <a:prstGeom prst="ellipse">
-            <a:avLst/>
-          </a:prstGeom>
-          <a:solidFill>
-            <a:srgbClr val="FFD98A"/>
-          </a:solidFill>
-          <a:ln/>
-        </p:spPr>
-      </p:sp>
-      <p:sp>
-        <p:nvSpPr>
-          <p:cNvPr id="10" name="Shape 8"/>
-          <p:cNvSpPr/>
-          <p:nvPr/>
-        </p:nvSpPr>
-        <p:spPr>
-          <a:xfrm>
-            <a:off x="2002536" y="4892040"/>
-            <a:ext cx="402336" cy="402336"/>
-          </a:xfrm>
-          <a:prstGeom prst="ellipse">
-            <a:avLst/>
-          </a:prstGeom>
-          <a:solidFill>
-            <a:srgbClr val="B9C4D4"/>
-          </a:solidFill>
-          <a:ln/>
-        </p:spPr>
-      </p:sp>
-      <p:sp>
-        <p:nvSpPr>
-          <p:cNvPr id="11" name="Shape 9"/>
-          <p:cNvSpPr/>
-          <p:nvPr/>
-        </p:nvSpPr>
-        <p:spPr>
-          <a:xfrm>
-            <a:off x="2569464" y="4892040"/>
-            <a:ext cx="402336" cy="402336"/>
-          </a:xfrm>
-          <a:prstGeom prst="ellipse">
-            <a:avLst/>
-          </a:prstGeom>
-          <a:solidFill>
-            <a:srgbClr val="7FA8D9"/>
-          </a:solidFill>
-          <a:ln/>
-        </p:spPr>
-      </p:sp>
-      <p:sp>
-        <p:nvSpPr>
-          <p:cNvPr id="12" name="Shape 10"/>
-          <p:cNvSpPr/>
-          <p:nvPr/>
-        </p:nvSpPr>
-        <p:spPr>
-          <a:xfrm>
-            <a:off x="3136392" y="4892040"/>
-            <a:ext cx="402336" cy="402336"/>
-          </a:xfrm>
-          <a:prstGeom prst="ellipse">
-            <a:avLst/>
-          </a:prstGeom>
-          <a:solidFill>
-            <a:srgbClr val="8B7FD9"/>
-          </a:solidFill>
-          <a:ln/>
-        </p:spPr>
-      </p:sp>
-      <p:sp>
-        <p:nvSpPr>
-          <p:cNvPr id="13" name="Text 11"/>
-          <p:cNvSpPr/>
-          <p:nvPr/>
-        </p:nvSpPr>
-        <p:spPr>
-          <a:xfrm>
-            <a:off x="3886200" y="4892040"/>
-            <a:ext cx="4572000" cy="402336"/>
+      <p:pic>
+        <p:nvPicPr>
+          <p:cNvPr id="8" name="Image 0" descr="preencoded.png">    </p:cNvPr>
+          <p:cNvPicPr>
+            <a:picLocks noChangeAspect="1"/>
+          </p:cNvPicPr>
+          <p:nvPr/>
+        </p:nvPicPr>
+        <p:blipFill>
+          <a:blip r:embed="rId1"/>
+          <a:stretch>
+            <a:fillRect/>
+          </a:stretch>
+        </p:blipFill>
+        <p:spPr>
+          <a:xfrm>
+            <a:off x="868680" y="4846320"/>
+            <a:ext cx="457200" cy="457200"/>
+          </a:xfrm>
+          <a:prstGeom prst="rect">
+            <a:avLst/>
+          </a:prstGeom>
+        </p:spPr>
+      </p:pic>
+      <p:pic>
+        <p:nvPicPr>
+          <p:cNvPr id="9" name="Image 1" descr="preencoded.png">    </p:cNvPr>
+          <p:cNvPicPr>
+            <a:picLocks noChangeAspect="1"/>
+          </p:cNvPicPr>
+          <p:nvPr/>
+        </p:nvPicPr>
+        <p:blipFill>
+          <a:blip r:embed="rId2"/>
+          <a:stretch>
+            <a:fillRect/>
+          </a:stretch>
+        </p:blipFill>
+        <p:spPr>
+          <a:xfrm>
+            <a:off x="1435608" y="4846320"/>
+            <a:ext cx="457200" cy="457200"/>
+          </a:xfrm>
+          <a:prstGeom prst="rect">
+            <a:avLst/>
+          </a:prstGeom>
+        </p:spPr>
+      </p:pic>
+      <p:pic>
+        <p:nvPicPr>
+          <p:cNvPr id="10" name="Image 2" descr="preencoded.png">    </p:cNvPr>
+          <p:cNvPicPr>
+            <a:picLocks noChangeAspect="1"/>
+          </p:cNvPicPr>
+          <p:nvPr/>
+        </p:nvPicPr>
+        <p:blipFill>
+          <a:blip r:embed="rId3"/>
+          <a:stretch>
+            <a:fillRect/>
+          </a:stretch>
+        </p:blipFill>
+        <p:spPr>
+          <a:xfrm>
+            <a:off x="2002536" y="4846320"/>
+            <a:ext cx="457200" cy="457200"/>
+          </a:xfrm>
+          <a:prstGeom prst="rect">
+            <a:avLst/>
+          </a:prstGeom>
+        </p:spPr>
+      </p:pic>
+      <p:pic>
+        <p:nvPicPr>
+          <p:cNvPr id="11" name="Image 3" descr="preencoded.png">    </p:cNvPr>
+          <p:cNvPicPr>
+            <a:picLocks noChangeAspect="1"/>
+          </p:cNvPicPr>
+          <p:nvPr/>
+        </p:nvPicPr>
+        <p:blipFill>
+          <a:blip r:embed="rId4"/>
+          <a:stretch>
+            <a:fillRect/>
+          </a:stretch>
+        </p:blipFill>
+        <p:spPr>
+          <a:xfrm>
+            <a:off x="2569464" y="4846320"/>
+            <a:ext cx="457200" cy="457200"/>
+          </a:xfrm>
+          <a:prstGeom prst="rect">
+            <a:avLst/>
+          </a:prstGeom>
+        </p:spPr>
+      </p:pic>
+      <p:pic>
+        <p:nvPicPr>
+          <p:cNvPr id="12" name="Image 4" descr="preencoded.png">    </p:cNvPr>
+          <p:cNvPicPr>
+            <a:picLocks noChangeAspect="1"/>
+          </p:cNvPicPr>
+          <p:nvPr/>
+        </p:nvPicPr>
+        <p:blipFill>
+          <a:blip r:embed="rId5"/>
+          <a:stretch>
+            <a:fillRect/>
+          </a:stretch>
+        </p:blipFill>
+        <p:spPr>
+          <a:xfrm>
+            <a:off x="3136392" y="4846320"/>
+            <a:ext cx="457200" cy="457200"/>
+          </a:xfrm>
+          <a:prstGeom prst="rect">
+            <a:avLst/>
+          </a:prstGeom>
+        </p:spPr>
+      </p:pic>
+      <p:sp>
+        <p:nvSpPr>
+          <p:cNvPr id="13" name="Text 6"/>
+          <p:cNvSpPr/>
+          <p:nvPr/>
+        </p:nvSpPr>
+        <p:spPr>
+          <a:xfrm>
+            <a:off x="3977640" y="4846320"/>
+            <a:ext cx="4572000" cy="457200"/>
           </a:xfrm>
           <a:prstGeom prst="rect">
             <a:avLst/>
@@ -2259,7 +2279,7 @@
       </p:sp>
       <p:sp>
         <p:nvSpPr>
-          <p:cNvPr id="14" name="Text 12"/>
+          <p:cNvPr id="14" name="Text 7"/>
           <p:cNvSpPr/>
           <p:nvPr/>
         </p:nvSpPr>
@@ -4167,109 +4187,129 @@
           </a:p>
         </p:txBody>
       </p:sp>
-      <p:sp>
-        <p:nvSpPr>
-          <p:cNvPr id="7" name="Shape 5"/>
-          <p:cNvSpPr/>
-          <p:nvPr/>
-        </p:nvSpPr>
-        <p:spPr>
-          <a:xfrm>
-            <a:off x="868680" y="5440680"/>
-            <a:ext cx="402336" cy="402336"/>
-          </a:xfrm>
-          <a:prstGeom prst="ellipse">
-            <a:avLst/>
-          </a:prstGeom>
-          <a:solidFill>
-            <a:srgbClr val="FFCF4A"/>
-          </a:solidFill>
-          <a:ln/>
-        </p:spPr>
-      </p:sp>
-      <p:sp>
-        <p:nvSpPr>
-          <p:cNvPr id="8" name="Shape 6"/>
-          <p:cNvSpPr/>
-          <p:nvPr/>
-        </p:nvSpPr>
-        <p:spPr>
-          <a:xfrm>
-            <a:off x="1435608" y="5440680"/>
-            <a:ext cx="402336" cy="402336"/>
-          </a:xfrm>
-          <a:prstGeom prst="ellipse">
-            <a:avLst/>
-          </a:prstGeom>
-          <a:solidFill>
-            <a:srgbClr val="FFD98A"/>
-          </a:solidFill>
-          <a:ln/>
-        </p:spPr>
-      </p:sp>
-      <p:sp>
-        <p:nvSpPr>
-          <p:cNvPr id="9" name="Shape 7"/>
-          <p:cNvSpPr/>
-          <p:nvPr/>
-        </p:nvSpPr>
-        <p:spPr>
-          <a:xfrm>
-            <a:off x="2002536" y="5440680"/>
-            <a:ext cx="402336" cy="402336"/>
-          </a:xfrm>
-          <a:prstGeom prst="ellipse">
-            <a:avLst/>
-          </a:prstGeom>
-          <a:solidFill>
-            <a:srgbClr val="B9C4D4"/>
-          </a:solidFill>
-          <a:ln/>
-        </p:spPr>
-      </p:sp>
-      <p:sp>
-        <p:nvSpPr>
-          <p:cNvPr id="10" name="Shape 8"/>
-          <p:cNvSpPr/>
-          <p:nvPr/>
-        </p:nvSpPr>
-        <p:spPr>
-          <a:xfrm>
-            <a:off x="2569464" y="5440680"/>
-            <a:ext cx="402336" cy="402336"/>
-          </a:xfrm>
-          <a:prstGeom prst="ellipse">
-            <a:avLst/>
-          </a:prstGeom>
-          <a:solidFill>
-            <a:srgbClr val="7FA8D9"/>
-          </a:solidFill>
-          <a:ln/>
-        </p:spPr>
-      </p:sp>
-      <p:sp>
-        <p:nvSpPr>
-          <p:cNvPr id="11" name="Shape 9"/>
-          <p:cNvSpPr/>
-          <p:nvPr/>
-        </p:nvSpPr>
-        <p:spPr>
-          <a:xfrm>
-            <a:off x="3136392" y="5440680"/>
-            <a:ext cx="402336" cy="402336"/>
-          </a:xfrm>
-          <a:prstGeom prst="ellipse">
-            <a:avLst/>
-          </a:prstGeom>
-          <a:solidFill>
-            <a:srgbClr val="8B7FD9"/>
-          </a:solidFill>
-          <a:ln/>
-        </p:spPr>
-      </p:sp>
-      <p:sp>
-        <p:nvSpPr>
-          <p:cNvPr id="12" name="Text 10"/>
+      <p:pic>
+        <p:nvPicPr>
+          <p:cNvPr id="7" name="Image 0" descr="preencoded.png">    </p:cNvPr>
+          <p:cNvPicPr>
+            <a:picLocks noChangeAspect="1"/>
+          </p:cNvPicPr>
+          <p:nvPr/>
+        </p:nvPicPr>
+        <p:blipFill>
+          <a:blip r:embed="rId1"/>
+          <a:stretch>
+            <a:fillRect/>
+          </a:stretch>
+        </p:blipFill>
+        <p:spPr>
+          <a:xfrm>
+            <a:off x="868680" y="5394960"/>
+            <a:ext cx="457200" cy="457200"/>
+          </a:xfrm>
+          <a:prstGeom prst="rect">
+            <a:avLst/>
+          </a:prstGeom>
+        </p:spPr>
+      </p:pic>
+      <p:pic>
+        <p:nvPicPr>
+          <p:cNvPr id="8" name="Image 1" descr="preencoded.png">    </p:cNvPr>
+          <p:cNvPicPr>
+            <a:picLocks noChangeAspect="1"/>
+          </p:cNvPicPr>
+          <p:nvPr/>
+        </p:nvPicPr>
+        <p:blipFill>
+          <a:blip r:embed="rId2"/>
+          <a:stretch>
+            <a:fillRect/>
+          </a:stretch>
+        </p:blipFill>
+        <p:spPr>
+          <a:xfrm>
+            <a:off x="1435608" y="5394960"/>
+            <a:ext cx="457200" cy="457200"/>
+          </a:xfrm>
+          <a:prstGeom prst="rect">
+            <a:avLst/>
+          </a:prstGeom>
+        </p:spPr>
+      </p:pic>
+      <p:pic>
+        <p:nvPicPr>
+          <p:cNvPr id="9" name="Image 2" descr="preencoded.png">    </p:cNvPr>
+          <p:cNvPicPr>
+            <a:picLocks noChangeAspect="1"/>
+          </p:cNvPicPr>
+          <p:nvPr/>
+        </p:nvPicPr>
+        <p:blipFill>
+          <a:blip r:embed="rId3"/>
+          <a:stretch>
+            <a:fillRect/>
+          </a:stretch>
+        </p:blipFill>
+        <p:spPr>
+          <a:xfrm>
+            <a:off x="2002536" y="5394960"/>
+            <a:ext cx="457200" cy="457200"/>
+          </a:xfrm>
+          <a:prstGeom prst="rect">
+            <a:avLst/>
+          </a:prstGeom>
+        </p:spPr>
+      </p:pic>
+      <p:pic>
+        <p:nvPicPr>
+          <p:cNvPr id="10" name="Image 3" descr="preencoded.png">    </p:cNvPr>
+          <p:cNvPicPr>
+            <a:picLocks noChangeAspect="1"/>
+          </p:cNvPicPr>
+          <p:nvPr/>
+        </p:nvPicPr>
+        <p:blipFill>
+          <a:blip r:embed="rId4"/>
+          <a:stretch>
+            <a:fillRect/>
+          </a:stretch>
+        </p:blipFill>
+        <p:spPr>
+          <a:xfrm>
+            <a:off x="2569464" y="5394960"/>
+            <a:ext cx="457200" cy="457200"/>
+          </a:xfrm>
+          <a:prstGeom prst="rect">
+            <a:avLst/>
+          </a:prstGeom>
+        </p:spPr>
+      </p:pic>
+      <p:pic>
+        <p:nvPicPr>
+          <p:cNvPr id="11" name="Image 4" descr="preencoded.png">    </p:cNvPr>
+          <p:cNvPicPr>
+            <a:picLocks noChangeAspect="1"/>
+          </p:cNvPicPr>
+          <p:nvPr/>
+        </p:nvPicPr>
+        <p:blipFill>
+          <a:blip r:embed="rId5"/>
+          <a:stretch>
+            <a:fillRect/>
+          </a:stretch>
+        </p:blipFill>
+        <p:spPr>
+          <a:xfrm>
+            <a:off x="3136392" y="5394960"/>
+            <a:ext cx="457200" cy="457200"/>
+          </a:xfrm>
+          <a:prstGeom prst="rect">
+            <a:avLst/>
+          </a:prstGeom>
+        </p:spPr>
+      </p:pic>
+      <p:sp>
+        <p:nvSpPr>
+          <p:cNvPr id="12" name="Text 5"/>
           <p:cNvSpPr/>
           <p:nvPr/>
         </p:nvSpPr>
@@ -5231,150 +5271,135 @@
                 <a:ea typeface="Calibri" pitchFamily="34" charset="-122"/>
                 <a:cs typeface="Calibri" pitchFamily="34" charset="-120"/>
               </a:rPr>
-              <a:t>“How's your weather today?”</a:t>
+              <a:t>“How are you feeling today?”</a:t>
             </a:r>
             <a:endParaRPr lang="en-US" sz="1400" dirty="0"/>
           </a:p>
         </p:txBody>
       </p:sp>
-      <p:sp>
-        <p:nvSpPr>
-          <p:cNvPr id="9" name="Shape 7"/>
-          <p:cNvSpPr/>
-          <p:nvPr/>
-        </p:nvSpPr>
+      <p:pic>
+        <p:nvPicPr>
+          <p:cNvPr id="9" name="Image 0" descr="preencoded.png">    </p:cNvPr>
+          <p:cNvPicPr>
+            <a:picLocks noChangeAspect="1"/>
+          </p:cNvPicPr>
+          <p:nvPr/>
+        </p:nvPicPr>
+        <p:blipFill>
+          <a:blip r:embed="rId1"/>
+          <a:stretch>
+            <a:fillRect/>
+          </a:stretch>
+        </p:blipFill>
         <p:spPr>
           <a:xfrm>
             <a:off x="1051560" y="3401568"/>
-            <a:ext cx="530352" cy="530352"/>
-          </a:xfrm>
-          <a:prstGeom prst="ellipse">
-            <a:avLst/>
-          </a:prstGeom>
-          <a:solidFill>
-            <a:srgbClr val="FFCF4A"/>
-          </a:solidFill>
-          <a:ln/>
-          <a:effectLst>
-            <a:outerShdw sx="100000" sy="100000" kx="0" ky="0" algn="bl" rotWithShape="0" blurRad="177800" dist="38100" dir="5400000">
-              <a:srgbClr val="0B1220">
-                <a:alpha val="16000"/>
-              </a:srgbClr>
-            </a:outerShdw>
-          </a:effectLst>
-        </p:spPr>
-      </p:sp>
-      <p:sp>
-        <p:nvSpPr>
-          <p:cNvPr id="10" name="Shape 8"/>
-          <p:cNvSpPr/>
-          <p:nvPr/>
-        </p:nvSpPr>
+            <a:ext cx="566928" cy="566928"/>
+          </a:xfrm>
+          <a:prstGeom prst="rect">
+            <a:avLst/>
+          </a:prstGeom>
+        </p:spPr>
+      </p:pic>
+      <p:pic>
+        <p:nvPicPr>
+          <p:cNvPr id="10" name="Image 1" descr="preencoded.png">    </p:cNvPr>
+          <p:cNvPicPr>
+            <a:picLocks noChangeAspect="1"/>
+          </p:cNvPicPr>
+          <p:nvPr/>
+        </p:nvPicPr>
+        <p:blipFill>
+          <a:blip r:embed="rId2"/>
+          <a:stretch>
+            <a:fillRect/>
+          </a:stretch>
+        </p:blipFill>
         <p:spPr>
           <a:xfrm>
             <a:off x="1764792" y="3401568"/>
-            <a:ext cx="530352" cy="530352"/>
-          </a:xfrm>
-          <a:prstGeom prst="ellipse">
-            <a:avLst/>
-          </a:prstGeom>
-          <a:solidFill>
-            <a:srgbClr val="FFD98A"/>
-          </a:solidFill>
-          <a:ln/>
-          <a:effectLst>
-            <a:outerShdw sx="100000" sy="100000" kx="0" ky="0" algn="bl" rotWithShape="0" blurRad="177800" dist="38100" dir="5400000">
-              <a:srgbClr val="0B1220">
-                <a:alpha val="16000"/>
-              </a:srgbClr>
-            </a:outerShdw>
-          </a:effectLst>
-        </p:spPr>
-      </p:sp>
-      <p:sp>
-        <p:nvSpPr>
-          <p:cNvPr id="11" name="Shape 9"/>
-          <p:cNvSpPr/>
-          <p:nvPr/>
-        </p:nvSpPr>
+            <a:ext cx="566928" cy="566928"/>
+          </a:xfrm>
+          <a:prstGeom prst="rect">
+            <a:avLst/>
+          </a:prstGeom>
+        </p:spPr>
+      </p:pic>
+      <p:pic>
+        <p:nvPicPr>
+          <p:cNvPr id="11" name="Image 2" descr="preencoded.png">    </p:cNvPr>
+          <p:cNvPicPr>
+            <a:picLocks noChangeAspect="1"/>
+          </p:cNvPicPr>
+          <p:nvPr/>
+        </p:nvPicPr>
+        <p:blipFill>
+          <a:blip r:embed="rId3"/>
+          <a:stretch>
+            <a:fillRect/>
+          </a:stretch>
+        </p:blipFill>
         <p:spPr>
           <a:xfrm>
             <a:off x="2478024" y="3401568"/>
-            <a:ext cx="530352" cy="530352"/>
-          </a:xfrm>
-          <a:prstGeom prst="ellipse">
-            <a:avLst/>
-          </a:prstGeom>
-          <a:solidFill>
-            <a:srgbClr val="B9C4D4"/>
-          </a:solidFill>
-          <a:ln/>
-          <a:effectLst>
-            <a:outerShdw sx="100000" sy="100000" kx="0" ky="0" algn="bl" rotWithShape="0" blurRad="177800" dist="38100" dir="5400000">
-              <a:srgbClr val="0B1220">
-                <a:alpha val="16000"/>
-              </a:srgbClr>
-            </a:outerShdw>
-          </a:effectLst>
-        </p:spPr>
-      </p:sp>
-      <p:sp>
-        <p:nvSpPr>
-          <p:cNvPr id="12" name="Shape 10"/>
-          <p:cNvSpPr/>
-          <p:nvPr/>
-        </p:nvSpPr>
+            <a:ext cx="566928" cy="566928"/>
+          </a:xfrm>
+          <a:prstGeom prst="rect">
+            <a:avLst/>
+          </a:prstGeom>
+        </p:spPr>
+      </p:pic>
+      <p:pic>
+        <p:nvPicPr>
+          <p:cNvPr id="12" name="Image 3" descr="preencoded.png">    </p:cNvPr>
+          <p:cNvPicPr>
+            <a:picLocks noChangeAspect="1"/>
+          </p:cNvPicPr>
+          <p:nvPr/>
+        </p:nvPicPr>
+        <p:blipFill>
+          <a:blip r:embed="rId4"/>
+          <a:stretch>
+            <a:fillRect/>
+          </a:stretch>
+        </p:blipFill>
         <p:spPr>
           <a:xfrm>
             <a:off x="3191256" y="3401568"/>
-            <a:ext cx="530352" cy="530352"/>
-          </a:xfrm>
-          <a:prstGeom prst="ellipse">
-            <a:avLst/>
-          </a:prstGeom>
-          <a:solidFill>
-            <a:srgbClr val="7FA8D9"/>
-          </a:solidFill>
-          <a:ln/>
-          <a:effectLst>
-            <a:outerShdw sx="100000" sy="100000" kx="0" ky="0" algn="bl" rotWithShape="0" blurRad="177800" dist="38100" dir="5400000">
-              <a:srgbClr val="0B1220">
-                <a:alpha val="16000"/>
-              </a:srgbClr>
-            </a:outerShdw>
-          </a:effectLst>
-        </p:spPr>
-      </p:sp>
-      <p:sp>
-        <p:nvSpPr>
-          <p:cNvPr id="13" name="Shape 11"/>
-          <p:cNvSpPr/>
-          <p:nvPr/>
-        </p:nvSpPr>
+            <a:ext cx="566928" cy="566928"/>
+          </a:xfrm>
+          <a:prstGeom prst="rect">
+            <a:avLst/>
+          </a:prstGeom>
+        </p:spPr>
+      </p:pic>
+      <p:pic>
+        <p:nvPicPr>
+          <p:cNvPr id="13" name="Image 4" descr="preencoded.png">    </p:cNvPr>
+          <p:cNvPicPr>
+            <a:picLocks noChangeAspect="1"/>
+          </p:cNvPicPr>
+          <p:nvPr/>
+        </p:nvPicPr>
+        <p:blipFill>
+          <a:blip r:embed="rId5"/>
+          <a:stretch>
+            <a:fillRect/>
+          </a:stretch>
+        </p:blipFill>
         <p:spPr>
           <a:xfrm>
             <a:off x="3904488" y="3401568"/>
-            <a:ext cx="530352" cy="530352"/>
-          </a:xfrm>
-          <a:prstGeom prst="ellipse">
-            <a:avLst/>
-          </a:prstGeom>
-          <a:solidFill>
-            <a:srgbClr val="8B7FD9"/>
-          </a:solidFill>
-          <a:ln/>
-          <a:effectLst>
-            <a:outerShdw sx="100000" sy="100000" kx="0" ky="0" algn="bl" rotWithShape="0" blurRad="177800" dist="38100" dir="5400000">
-              <a:srgbClr val="0B1220">
-                <a:alpha val="16000"/>
-              </a:srgbClr>
-            </a:outerShdw>
-          </a:effectLst>
-        </p:spPr>
-      </p:sp>
-      <p:sp>
-        <p:nvSpPr>
-          <p:cNvPr id="14" name="Text 12"/>
+            <a:ext cx="566928" cy="566928"/>
+          </a:xfrm>
+          <a:prstGeom prst="rect">
+            <a:avLst/>
+          </a:prstGeom>
+        </p:spPr>
+      </p:pic>
+      <p:sp>
+        <p:nvSpPr>
+          <p:cNvPr id="14" name="Text 7"/>
           <p:cNvSpPr/>
           <p:nvPr/>
         </p:nvSpPr>
@@ -5409,7 +5434,7 @@
                 <a:ea typeface="Calibri" pitchFamily="34" charset="-122"/>
                 <a:cs typeface="Calibri" pitchFamily="34" charset="-120"/>
               </a:rPr>
-              <a:t>Weather, not words — no vocabulary needed</a:t>
+              <a:t>Faces, not words — no vocabulary needed</a:t>
             </a:r>
             <a:endParaRPr lang="en-US" sz="1250" dirty="0"/>
           </a:p>
@@ -5459,7 +5484,7 @@
       </p:sp>
       <p:sp>
         <p:nvSpPr>
-          <p:cNvPr id="15" name="Shape 13"/>
+          <p:cNvPr id="15" name="Shape 8"/>
           <p:cNvSpPr/>
           <p:nvPr/>
         </p:nvSpPr>
@@ -5493,7 +5518,7 @@
       </p:sp>
       <p:sp>
         <p:nvSpPr>
-          <p:cNvPr id="16" name="Shape 14"/>
+          <p:cNvPr id="16" name="Shape 9"/>
           <p:cNvSpPr/>
           <p:nvPr/>
         </p:nvSpPr>
@@ -5520,7 +5545,7 @@
       </p:sp>
       <p:sp>
         <p:nvSpPr>
-          <p:cNvPr id="17" name="Text 15"/>
+          <p:cNvPr id="17" name="Text 10"/>
           <p:cNvSpPr/>
           <p:nvPr/>
         </p:nvSpPr>
@@ -5559,7 +5584,7 @@
       </p:sp>
       <p:sp>
         <p:nvSpPr>
-          <p:cNvPr id="18" name="Text 16"/>
+          <p:cNvPr id="18" name="Text 11"/>
           <p:cNvSpPr/>
           <p:nvPr/>
         </p:nvSpPr>
@@ -5598,7 +5623,7 @@
       </p:sp>
       <p:sp>
         <p:nvSpPr>
-          <p:cNvPr id="19" name="Text 17"/>
+          <p:cNvPr id="19" name="Text 12"/>
           <p:cNvSpPr/>
           <p:nvPr/>
         </p:nvSpPr>
@@ -5635,249 +5660,297 @@
           </a:p>
         </p:txBody>
       </p:sp>
-      <p:sp>
-        <p:nvSpPr>
-          <p:cNvPr id="20" name="Shape 18"/>
-          <p:cNvSpPr/>
-          <p:nvPr/>
-        </p:nvSpPr>
+      <p:pic>
+        <p:nvPicPr>
+          <p:cNvPr id="20" name="Image 5" descr="preencoded.png">    </p:cNvPr>
+          <p:cNvPicPr>
+            <a:picLocks noChangeAspect="1"/>
+          </p:cNvPicPr>
+          <p:nvPr/>
+        </p:nvPicPr>
+        <p:blipFill>
+          <a:blip r:embed="rId6"/>
+          <a:stretch>
+            <a:fillRect/>
+          </a:stretch>
+        </p:blipFill>
         <p:spPr>
           <a:xfrm>
             <a:off x="6583680" y="3401568"/>
-            <a:ext cx="292608" cy="292608"/>
-          </a:xfrm>
-          <a:prstGeom prst="ellipse">
-            <a:avLst/>
-          </a:prstGeom>
-          <a:solidFill>
-            <a:srgbClr val="FFCF4A"/>
-          </a:solidFill>
-          <a:ln/>
-        </p:spPr>
-      </p:sp>
-      <p:sp>
-        <p:nvSpPr>
-          <p:cNvPr id="21" name="Shape 19"/>
-          <p:cNvSpPr/>
-          <p:nvPr/>
-        </p:nvSpPr>
+            <a:ext cx="310896" cy="310896"/>
+          </a:xfrm>
+          <a:prstGeom prst="rect">
+            <a:avLst/>
+          </a:prstGeom>
+        </p:spPr>
+      </p:pic>
+      <p:pic>
+        <p:nvPicPr>
+          <p:cNvPr id="21" name="Image 6" descr="preencoded.png">    </p:cNvPr>
+          <p:cNvPicPr>
+            <a:picLocks noChangeAspect="1"/>
+          </p:cNvPicPr>
+          <p:nvPr/>
+        </p:nvPicPr>
+        <p:blipFill>
+          <a:blip r:embed="rId7"/>
+          <a:stretch>
+            <a:fillRect/>
+          </a:stretch>
+        </p:blipFill>
         <p:spPr>
           <a:xfrm>
             <a:off x="6967728" y="3401568"/>
-            <a:ext cx="292608" cy="292608"/>
-          </a:xfrm>
-          <a:prstGeom prst="ellipse">
-            <a:avLst/>
-          </a:prstGeom>
-          <a:solidFill>
-            <a:srgbClr val="FFCF4A"/>
-          </a:solidFill>
-          <a:ln/>
-        </p:spPr>
-      </p:sp>
-      <p:sp>
-        <p:nvSpPr>
-          <p:cNvPr id="22" name="Shape 20"/>
-          <p:cNvSpPr/>
-          <p:nvPr/>
-        </p:nvSpPr>
+            <a:ext cx="310896" cy="310896"/>
+          </a:xfrm>
+          <a:prstGeom prst="rect">
+            <a:avLst/>
+          </a:prstGeom>
+        </p:spPr>
+      </p:pic>
+      <p:pic>
+        <p:nvPicPr>
+          <p:cNvPr id="22" name="Image 7" descr="preencoded.png">    </p:cNvPr>
+          <p:cNvPicPr>
+            <a:picLocks noChangeAspect="1"/>
+          </p:cNvPicPr>
+          <p:nvPr/>
+        </p:nvPicPr>
+        <p:blipFill>
+          <a:blip r:embed="rId8"/>
+          <a:stretch>
+            <a:fillRect/>
+          </a:stretch>
+        </p:blipFill>
         <p:spPr>
           <a:xfrm>
             <a:off x="7351776" y="3401568"/>
-            <a:ext cx="292608" cy="292608"/>
-          </a:xfrm>
-          <a:prstGeom prst="ellipse">
-            <a:avLst/>
-          </a:prstGeom>
-          <a:solidFill>
-            <a:srgbClr val="7FA8D9"/>
-          </a:solidFill>
-          <a:ln/>
-        </p:spPr>
-      </p:sp>
-      <p:sp>
-        <p:nvSpPr>
-          <p:cNvPr id="23" name="Shape 21"/>
-          <p:cNvSpPr/>
-          <p:nvPr/>
-        </p:nvSpPr>
+            <a:ext cx="310896" cy="310896"/>
+          </a:xfrm>
+          <a:prstGeom prst="rect">
+            <a:avLst/>
+          </a:prstGeom>
+        </p:spPr>
+      </p:pic>
+      <p:pic>
+        <p:nvPicPr>
+          <p:cNvPr id="23" name="Image 8" descr="preencoded.png">    </p:cNvPr>
+          <p:cNvPicPr>
+            <a:picLocks noChangeAspect="1"/>
+          </p:cNvPicPr>
+          <p:nvPr/>
+        </p:nvPicPr>
+        <p:blipFill>
+          <a:blip r:embed="rId9"/>
+          <a:stretch>
+            <a:fillRect/>
+          </a:stretch>
+        </p:blipFill>
         <p:spPr>
           <a:xfrm>
             <a:off x="7735824" y="3401568"/>
-            <a:ext cx="292608" cy="292608"/>
-          </a:xfrm>
-          <a:prstGeom prst="ellipse">
-            <a:avLst/>
-          </a:prstGeom>
-          <a:solidFill>
-            <a:srgbClr val="FFCF4A"/>
-          </a:solidFill>
-          <a:ln/>
-        </p:spPr>
-      </p:sp>
-      <p:sp>
-        <p:nvSpPr>
-          <p:cNvPr id="24" name="Shape 22"/>
-          <p:cNvSpPr/>
-          <p:nvPr/>
-        </p:nvSpPr>
+            <a:ext cx="310896" cy="310896"/>
+          </a:xfrm>
+          <a:prstGeom prst="rect">
+            <a:avLst/>
+          </a:prstGeom>
+        </p:spPr>
+      </p:pic>
+      <p:pic>
+        <p:nvPicPr>
+          <p:cNvPr id="24" name="Image 9" descr="preencoded.png">    </p:cNvPr>
+          <p:cNvPicPr>
+            <a:picLocks noChangeAspect="1"/>
+          </p:cNvPicPr>
+          <p:nvPr/>
+        </p:nvPicPr>
+        <p:blipFill>
+          <a:blip r:embed="rId10"/>
+          <a:stretch>
+            <a:fillRect/>
+          </a:stretch>
+        </p:blipFill>
         <p:spPr>
           <a:xfrm>
             <a:off x="8119872" y="3401568"/>
-            <a:ext cx="292608" cy="292608"/>
-          </a:xfrm>
-          <a:prstGeom prst="ellipse">
-            <a:avLst/>
-          </a:prstGeom>
-          <a:solidFill>
-            <a:srgbClr val="FFD98A"/>
-          </a:solidFill>
-          <a:ln/>
-        </p:spPr>
-      </p:sp>
-      <p:sp>
-        <p:nvSpPr>
-          <p:cNvPr id="25" name="Shape 23"/>
-          <p:cNvSpPr/>
-          <p:nvPr/>
-        </p:nvSpPr>
+            <a:ext cx="310896" cy="310896"/>
+          </a:xfrm>
+          <a:prstGeom prst="rect">
+            <a:avLst/>
+          </a:prstGeom>
+        </p:spPr>
+      </p:pic>
+      <p:pic>
+        <p:nvPicPr>
+          <p:cNvPr id="25" name="Image 10" descr="preencoded.png">    </p:cNvPr>
+          <p:cNvPicPr>
+            <a:picLocks noChangeAspect="1"/>
+          </p:cNvPicPr>
+          <p:nvPr/>
+        </p:nvPicPr>
+        <p:blipFill>
+          <a:blip r:embed="rId11"/>
+          <a:stretch>
+            <a:fillRect/>
+          </a:stretch>
+        </p:blipFill>
         <p:spPr>
           <a:xfrm>
             <a:off x="8503920" y="3401568"/>
-            <a:ext cx="292608" cy="292608"/>
-          </a:xfrm>
-          <a:prstGeom prst="ellipse">
-            <a:avLst/>
-          </a:prstGeom>
-          <a:solidFill>
-            <a:srgbClr val="FFCF4A"/>
-          </a:solidFill>
-          <a:ln/>
-        </p:spPr>
-      </p:sp>
-      <p:sp>
-        <p:nvSpPr>
-          <p:cNvPr id="26" name="Shape 24"/>
-          <p:cNvSpPr/>
-          <p:nvPr/>
-        </p:nvSpPr>
+            <a:ext cx="310896" cy="310896"/>
+          </a:xfrm>
+          <a:prstGeom prst="rect">
+            <a:avLst/>
+          </a:prstGeom>
+        </p:spPr>
+      </p:pic>
+      <p:pic>
+        <p:nvPicPr>
+          <p:cNvPr id="26" name="Image 11" descr="preencoded.png">    </p:cNvPr>
+          <p:cNvPicPr>
+            <a:picLocks noChangeAspect="1"/>
+          </p:cNvPicPr>
+          <p:nvPr/>
+        </p:nvPicPr>
+        <p:blipFill>
+          <a:blip r:embed="rId12"/>
+          <a:stretch>
+            <a:fillRect/>
+          </a:stretch>
+        </p:blipFill>
         <p:spPr>
           <a:xfrm>
             <a:off x="6583680" y="3785616"/>
-            <a:ext cx="292608" cy="292608"/>
-          </a:xfrm>
-          <a:prstGeom prst="ellipse">
-            <a:avLst/>
-          </a:prstGeom>
-          <a:solidFill>
-            <a:srgbClr val="FFCF4A"/>
-          </a:solidFill>
-          <a:ln/>
-        </p:spPr>
-      </p:sp>
-      <p:sp>
-        <p:nvSpPr>
-          <p:cNvPr id="27" name="Shape 25"/>
-          <p:cNvSpPr/>
-          <p:nvPr/>
-        </p:nvSpPr>
+            <a:ext cx="310896" cy="310896"/>
+          </a:xfrm>
+          <a:prstGeom prst="rect">
+            <a:avLst/>
+          </a:prstGeom>
+        </p:spPr>
+      </p:pic>
+      <p:pic>
+        <p:nvPicPr>
+          <p:cNvPr id="27" name="Image 12" descr="preencoded.png">    </p:cNvPr>
+          <p:cNvPicPr>
+            <a:picLocks noChangeAspect="1"/>
+          </p:cNvPicPr>
+          <p:nvPr/>
+        </p:nvPicPr>
+        <p:blipFill>
+          <a:blip r:embed="rId13"/>
+          <a:stretch>
+            <a:fillRect/>
+          </a:stretch>
+        </p:blipFill>
         <p:spPr>
           <a:xfrm>
             <a:off x="6967728" y="3785616"/>
-            <a:ext cx="292608" cy="292608"/>
-          </a:xfrm>
-          <a:prstGeom prst="ellipse">
-            <a:avLst/>
-          </a:prstGeom>
-          <a:solidFill>
-            <a:srgbClr val="FFD98A"/>
-          </a:solidFill>
-          <a:ln/>
-        </p:spPr>
-      </p:sp>
-      <p:sp>
-        <p:nvSpPr>
-          <p:cNvPr id="28" name="Shape 26"/>
-          <p:cNvSpPr/>
-          <p:nvPr/>
-        </p:nvSpPr>
+            <a:ext cx="310896" cy="310896"/>
+          </a:xfrm>
+          <a:prstGeom prst="rect">
+            <a:avLst/>
+          </a:prstGeom>
+        </p:spPr>
+      </p:pic>
+      <p:pic>
+        <p:nvPicPr>
+          <p:cNvPr id="28" name="Image 13" descr="preencoded.png">    </p:cNvPr>
+          <p:cNvPicPr>
+            <a:picLocks noChangeAspect="1"/>
+          </p:cNvPicPr>
+          <p:nvPr/>
+        </p:nvPicPr>
+        <p:blipFill>
+          <a:blip r:embed="rId14"/>
+          <a:stretch>
+            <a:fillRect/>
+          </a:stretch>
+        </p:blipFill>
         <p:spPr>
           <a:xfrm>
             <a:off x="7351776" y="3785616"/>
-            <a:ext cx="292608" cy="292608"/>
-          </a:xfrm>
-          <a:prstGeom prst="ellipse">
-            <a:avLst/>
-          </a:prstGeom>
-          <a:solidFill>
-            <a:srgbClr val="FFCF4A"/>
-          </a:solidFill>
-          <a:ln/>
-        </p:spPr>
-      </p:sp>
-      <p:sp>
-        <p:nvSpPr>
-          <p:cNvPr id="29" name="Shape 27"/>
-          <p:cNvSpPr/>
-          <p:nvPr/>
-        </p:nvSpPr>
+            <a:ext cx="310896" cy="310896"/>
+          </a:xfrm>
+          <a:prstGeom prst="rect">
+            <a:avLst/>
+          </a:prstGeom>
+        </p:spPr>
+      </p:pic>
+      <p:pic>
+        <p:nvPicPr>
+          <p:cNvPr id="29" name="Image 14" descr="preencoded.png">    </p:cNvPr>
+          <p:cNvPicPr>
+            <a:picLocks noChangeAspect="1"/>
+          </p:cNvPicPr>
+          <p:nvPr/>
+        </p:nvPicPr>
+        <p:blipFill>
+          <a:blip r:embed="rId15"/>
+          <a:stretch>
+            <a:fillRect/>
+          </a:stretch>
+        </p:blipFill>
         <p:spPr>
           <a:xfrm>
             <a:off x="7735824" y="3785616"/>
-            <a:ext cx="292608" cy="292608"/>
-          </a:xfrm>
-          <a:prstGeom prst="ellipse">
-            <a:avLst/>
-          </a:prstGeom>
-          <a:solidFill>
-            <a:srgbClr val="8B7FD9"/>
-          </a:solidFill>
-          <a:ln/>
-        </p:spPr>
-      </p:sp>
-      <p:sp>
-        <p:nvSpPr>
-          <p:cNvPr id="30" name="Shape 28"/>
-          <p:cNvSpPr/>
-          <p:nvPr/>
-        </p:nvSpPr>
+            <a:ext cx="310896" cy="310896"/>
+          </a:xfrm>
+          <a:prstGeom prst="rect">
+            <a:avLst/>
+          </a:prstGeom>
+        </p:spPr>
+      </p:pic>
+      <p:pic>
+        <p:nvPicPr>
+          <p:cNvPr id="30" name="Image 15" descr="preencoded.png">    </p:cNvPr>
+          <p:cNvPicPr>
+            <a:picLocks noChangeAspect="1"/>
+          </p:cNvPicPr>
+          <p:nvPr/>
+        </p:nvPicPr>
+        <p:blipFill>
+          <a:blip r:embed="rId16"/>
+          <a:stretch>
+            <a:fillRect/>
+          </a:stretch>
+        </p:blipFill>
         <p:spPr>
           <a:xfrm>
             <a:off x="8119872" y="3785616"/>
-            <a:ext cx="292608" cy="292608"/>
-          </a:xfrm>
-          <a:prstGeom prst="ellipse">
-            <a:avLst/>
-          </a:prstGeom>
-          <a:solidFill>
-            <a:srgbClr val="7FA8D9"/>
-          </a:solidFill>
-          <a:ln/>
-        </p:spPr>
-      </p:sp>
-      <p:sp>
-        <p:nvSpPr>
-          <p:cNvPr id="31" name="Shape 29"/>
-          <p:cNvSpPr/>
-          <p:nvPr/>
-        </p:nvSpPr>
+            <a:ext cx="310896" cy="310896"/>
+          </a:xfrm>
+          <a:prstGeom prst="rect">
+            <a:avLst/>
+          </a:prstGeom>
+        </p:spPr>
+      </p:pic>
+      <p:pic>
+        <p:nvPicPr>
+          <p:cNvPr id="31" name="Image 16" descr="preencoded.png">    </p:cNvPr>
+          <p:cNvPicPr>
+            <a:picLocks noChangeAspect="1"/>
+          </p:cNvPicPr>
+          <p:nvPr/>
+        </p:nvPicPr>
+        <p:blipFill>
+          <a:blip r:embed="rId17"/>
+          <a:stretch>
+            <a:fillRect/>
+          </a:stretch>
+        </p:blipFill>
         <p:spPr>
           <a:xfrm>
             <a:off x="8503920" y="3785616"/>
-            <a:ext cx="292608" cy="292608"/>
-          </a:xfrm>
-          <a:prstGeom prst="ellipse">
-            <a:avLst/>
-          </a:prstGeom>
-          <a:solidFill>
-            <a:srgbClr val="FFCF4A"/>
-          </a:solidFill>
-          <a:ln/>
-        </p:spPr>
-      </p:sp>
-      <p:sp>
-        <p:nvSpPr>
-          <p:cNvPr id="32" name="Text 30"/>
+            <a:ext cx="310896" cy="310896"/>
+          </a:xfrm>
+          <a:prstGeom prst="rect">
+            <a:avLst/>
+          </a:prstGeom>
+        </p:spPr>
+      </p:pic>
+      <p:sp>
+        <p:nvSpPr>
+          <p:cNvPr id="32" name="Text 13"/>
           <p:cNvSpPr/>
           <p:nvPr/>
         </p:nvSpPr>
@@ -5962,7 +6035,7 @@
       </p:sp>
       <p:sp>
         <p:nvSpPr>
-          <p:cNvPr id="33" name="Text 31"/>
+          <p:cNvPr id="33" name="Text 14"/>
           <p:cNvSpPr/>
           <p:nvPr/>
         </p:nvSpPr>
@@ -9384,7 +9457,7 @@
                 <a:ea typeface="Cambria" pitchFamily="34" charset="-122"/>
                 <a:cs typeface="Cambria" pitchFamily="34" charset="-120"/>
               </a:rPr>
-              <a:t>A cloudy day is not a signal</a:t>
+              <a:t>An “okay” day is not a signal</a:t>
             </a:r>
             <a:endParaRPr lang="en-US" sz="3800" dirty="0"/>
           </a:p>
@@ -9496,115 +9569,135 @@
                 <a:ea typeface="Cambria" pitchFamily="34" charset="-122"/>
                 <a:cs typeface="Cambria" pitchFamily="34" charset="-120"/>
               </a:rPr>
-              <a:t>Ana checks in “cloudy” most days</a:t>
+              <a:t>Ana checks in “okay” most days</a:t>
             </a:r>
             <a:endParaRPr lang="en-US" sz="1900" dirty="0"/>
           </a:p>
         </p:txBody>
       </p:sp>
-      <p:sp>
-        <p:nvSpPr>
-          <p:cNvPr id="6" name="Shape 4"/>
-          <p:cNvSpPr/>
-          <p:nvPr/>
-        </p:nvSpPr>
+      <p:pic>
+        <p:nvPicPr>
+          <p:cNvPr id="6" name="Image 0" descr="preencoded.png">    </p:cNvPr>
+          <p:cNvPicPr>
+            <a:picLocks noChangeAspect="1"/>
+          </p:cNvPicPr>
+          <p:nvPr/>
+        </p:nvPicPr>
+        <p:blipFill>
+          <a:blip r:embed="rId1"/>
+          <a:stretch>
+            <a:fillRect/>
+          </a:stretch>
+        </p:blipFill>
         <p:spPr>
           <a:xfrm>
             <a:off x="1051560" y="2926080"/>
-            <a:ext cx="475488" cy="475488"/>
-          </a:xfrm>
-          <a:prstGeom prst="ellipse">
-            <a:avLst/>
-          </a:prstGeom>
-          <a:solidFill>
-            <a:srgbClr val="B9C4D4"/>
-          </a:solidFill>
-          <a:ln/>
-        </p:spPr>
-      </p:sp>
-      <p:sp>
-        <p:nvSpPr>
-          <p:cNvPr id="7" name="Shape 5"/>
-          <p:cNvSpPr/>
-          <p:nvPr/>
-        </p:nvSpPr>
+            <a:ext cx="512064" cy="512064"/>
+          </a:xfrm>
+          <a:prstGeom prst="rect">
+            <a:avLst/>
+          </a:prstGeom>
+        </p:spPr>
+      </p:pic>
+      <p:pic>
+        <p:nvPicPr>
+          <p:cNvPr id="7" name="Image 1" descr="preencoded.png">    </p:cNvPr>
+          <p:cNvPicPr>
+            <a:picLocks noChangeAspect="1"/>
+          </p:cNvPicPr>
+          <p:nvPr/>
+        </p:nvPicPr>
+        <p:blipFill>
+          <a:blip r:embed="rId2"/>
+          <a:stretch>
+            <a:fillRect/>
+          </a:stretch>
+        </p:blipFill>
         <p:spPr>
           <a:xfrm>
             <a:off x="1709928" y="2926080"/>
-            <a:ext cx="475488" cy="475488"/>
-          </a:xfrm>
-          <a:prstGeom prst="ellipse">
-            <a:avLst/>
-          </a:prstGeom>
-          <a:solidFill>
-            <a:srgbClr val="B9C4D4"/>
-          </a:solidFill>
-          <a:ln/>
-        </p:spPr>
-      </p:sp>
-      <p:sp>
-        <p:nvSpPr>
-          <p:cNvPr id="8" name="Shape 6"/>
-          <p:cNvSpPr/>
-          <p:nvPr/>
-        </p:nvSpPr>
+            <a:ext cx="512064" cy="512064"/>
+          </a:xfrm>
+          <a:prstGeom prst="rect">
+            <a:avLst/>
+          </a:prstGeom>
+        </p:spPr>
+      </p:pic>
+      <p:pic>
+        <p:nvPicPr>
+          <p:cNvPr id="8" name="Image 2" descr="preencoded.png">    </p:cNvPr>
+          <p:cNvPicPr>
+            <a:picLocks noChangeAspect="1"/>
+          </p:cNvPicPr>
+          <p:nvPr/>
+        </p:nvPicPr>
+        <p:blipFill>
+          <a:blip r:embed="rId3"/>
+          <a:stretch>
+            <a:fillRect/>
+          </a:stretch>
+        </p:blipFill>
         <p:spPr>
           <a:xfrm>
             <a:off x="2368296" y="2926080"/>
-            <a:ext cx="475488" cy="475488"/>
-          </a:xfrm>
-          <a:prstGeom prst="ellipse">
-            <a:avLst/>
-          </a:prstGeom>
-          <a:solidFill>
-            <a:srgbClr val="7FA8D9"/>
-          </a:solidFill>
-          <a:ln/>
-        </p:spPr>
-      </p:sp>
-      <p:sp>
-        <p:nvSpPr>
-          <p:cNvPr id="9" name="Shape 7"/>
-          <p:cNvSpPr/>
-          <p:nvPr/>
-        </p:nvSpPr>
+            <a:ext cx="512064" cy="512064"/>
+          </a:xfrm>
+          <a:prstGeom prst="rect">
+            <a:avLst/>
+          </a:prstGeom>
+        </p:spPr>
+      </p:pic>
+      <p:pic>
+        <p:nvPicPr>
+          <p:cNvPr id="9" name="Image 3" descr="preencoded.png">    </p:cNvPr>
+          <p:cNvPicPr>
+            <a:picLocks noChangeAspect="1"/>
+          </p:cNvPicPr>
+          <p:nvPr/>
+        </p:nvPicPr>
+        <p:blipFill>
+          <a:blip r:embed="rId4"/>
+          <a:stretch>
+            <a:fillRect/>
+          </a:stretch>
+        </p:blipFill>
         <p:spPr>
           <a:xfrm>
             <a:off x="3026664" y="2926080"/>
-            <a:ext cx="475488" cy="475488"/>
-          </a:xfrm>
-          <a:prstGeom prst="ellipse">
-            <a:avLst/>
-          </a:prstGeom>
-          <a:solidFill>
-            <a:srgbClr val="B9C4D4"/>
-          </a:solidFill>
-          <a:ln/>
-        </p:spPr>
-      </p:sp>
-      <p:sp>
-        <p:nvSpPr>
-          <p:cNvPr id="10" name="Shape 8"/>
-          <p:cNvSpPr/>
-          <p:nvPr/>
-        </p:nvSpPr>
+            <a:ext cx="512064" cy="512064"/>
+          </a:xfrm>
+          <a:prstGeom prst="rect">
+            <a:avLst/>
+          </a:prstGeom>
+        </p:spPr>
+      </p:pic>
+      <p:pic>
+        <p:nvPicPr>
+          <p:cNvPr id="10" name="Image 4" descr="preencoded.png">    </p:cNvPr>
+          <p:cNvPicPr>
+            <a:picLocks noChangeAspect="1"/>
+          </p:cNvPicPr>
+          <p:nvPr/>
+        </p:nvPicPr>
+        <p:blipFill>
+          <a:blip r:embed="rId5"/>
+          <a:stretch>
+            <a:fillRect/>
+          </a:stretch>
+        </p:blipFill>
         <p:spPr>
           <a:xfrm>
             <a:off x="3685032" y="2926080"/>
-            <a:ext cx="475488" cy="475488"/>
-          </a:xfrm>
-          <a:prstGeom prst="ellipse">
-            <a:avLst/>
-          </a:prstGeom>
-          <a:solidFill>
-            <a:srgbClr val="B9C4D4"/>
-          </a:solidFill>
-          <a:ln/>
-        </p:spPr>
-      </p:sp>
-      <p:sp>
-        <p:nvSpPr>
-          <p:cNvPr id="11" name="Text 9"/>
+            <a:ext cx="512064" cy="512064"/>
+          </a:xfrm>
+          <a:prstGeom prst="rect">
+            <a:avLst/>
+          </a:prstGeom>
+        </p:spPr>
+      </p:pic>
+      <p:sp>
+        <p:nvSpPr>
+          <p:cNvPr id="11" name="Text 4"/>
           <p:cNvSpPr/>
           <p:nvPr/>
         </p:nvSpPr>
@@ -9643,7 +9736,7 @@
       </p:sp>
       <p:sp>
         <p:nvSpPr>
-          <p:cNvPr id="12" name="Text 10"/>
+          <p:cNvPr id="12" name="Text 5"/>
           <p:cNvSpPr/>
           <p:nvPr/>
         </p:nvSpPr>
@@ -9685,7 +9778,7 @@
       </p:sp>
       <p:sp>
         <p:nvSpPr>
-          <p:cNvPr id="13" name="Shape 11"/>
+          <p:cNvPr id="13" name="Shape 6"/>
           <p:cNvSpPr/>
           <p:nvPr/>
         </p:nvSpPr>
@@ -9719,7 +9812,7 @@
       </p:sp>
       <p:sp>
         <p:nvSpPr>
-          <p:cNvPr id="14" name="Text 12"/>
+          <p:cNvPr id="14" name="Text 7"/>
           <p:cNvSpPr/>
           <p:nvPr/>
         </p:nvSpPr>
@@ -9750,115 +9843,135 @@
                 <a:ea typeface="Cambria" pitchFamily="34" charset="-122"/>
                 <a:cs typeface="Cambria" pitchFamily="34" charset="-120"/>
               </a:rPr>
-              <a:t>Ben checks in “sunny” most days</a:t>
+              <a:t>Ben checks in “great” most days</a:t>
             </a:r>
             <a:endParaRPr lang="en-US" sz="1900" dirty="0"/>
           </a:p>
         </p:txBody>
       </p:sp>
-      <p:sp>
-        <p:nvSpPr>
-          <p:cNvPr id="15" name="Shape 13"/>
-          <p:cNvSpPr/>
-          <p:nvPr/>
-        </p:nvSpPr>
+      <p:pic>
+        <p:nvPicPr>
+          <p:cNvPr id="15" name="Image 5" descr="preencoded.png">    </p:cNvPr>
+          <p:cNvPicPr>
+            <a:picLocks noChangeAspect="1"/>
+          </p:cNvPicPr>
+          <p:nvPr/>
+        </p:nvPicPr>
+        <p:blipFill>
+          <a:blip r:embed="rId6"/>
+          <a:stretch>
+            <a:fillRect/>
+          </a:stretch>
+        </p:blipFill>
         <p:spPr>
           <a:xfrm>
             <a:off x="6583680" y="2926080"/>
-            <a:ext cx="475488" cy="475488"/>
-          </a:xfrm>
-          <a:prstGeom prst="ellipse">
-            <a:avLst/>
-          </a:prstGeom>
-          <a:solidFill>
-            <a:srgbClr val="FFCF4A"/>
-          </a:solidFill>
-          <a:ln/>
-        </p:spPr>
-      </p:sp>
-      <p:sp>
-        <p:nvSpPr>
-          <p:cNvPr id="16" name="Shape 14"/>
-          <p:cNvSpPr/>
-          <p:nvPr/>
-        </p:nvSpPr>
+            <a:ext cx="512064" cy="512064"/>
+          </a:xfrm>
+          <a:prstGeom prst="rect">
+            <a:avLst/>
+          </a:prstGeom>
+        </p:spPr>
+      </p:pic>
+      <p:pic>
+        <p:nvPicPr>
+          <p:cNvPr id="16" name="Image 6" descr="preencoded.png">    </p:cNvPr>
+          <p:cNvPicPr>
+            <a:picLocks noChangeAspect="1"/>
+          </p:cNvPicPr>
+          <p:nvPr/>
+        </p:nvPicPr>
+        <p:blipFill>
+          <a:blip r:embed="rId7"/>
+          <a:stretch>
+            <a:fillRect/>
+          </a:stretch>
+        </p:blipFill>
         <p:spPr>
           <a:xfrm>
             <a:off x="7242048" y="2926080"/>
-            <a:ext cx="475488" cy="475488"/>
-          </a:xfrm>
-          <a:prstGeom prst="ellipse">
-            <a:avLst/>
-          </a:prstGeom>
-          <a:solidFill>
-            <a:srgbClr val="FFCF4A"/>
-          </a:solidFill>
-          <a:ln/>
-        </p:spPr>
-      </p:sp>
-      <p:sp>
-        <p:nvSpPr>
-          <p:cNvPr id="17" name="Shape 15"/>
-          <p:cNvSpPr/>
-          <p:nvPr/>
-        </p:nvSpPr>
+            <a:ext cx="512064" cy="512064"/>
+          </a:xfrm>
+          <a:prstGeom prst="rect">
+            <a:avLst/>
+          </a:prstGeom>
+        </p:spPr>
+      </p:pic>
+      <p:pic>
+        <p:nvPicPr>
+          <p:cNvPr id="17" name="Image 7" descr="preencoded.png">    </p:cNvPr>
+          <p:cNvPicPr>
+            <a:picLocks noChangeAspect="1"/>
+          </p:cNvPicPr>
+          <p:nvPr/>
+        </p:nvPicPr>
+        <p:blipFill>
+          <a:blip r:embed="rId8"/>
+          <a:stretch>
+            <a:fillRect/>
+          </a:stretch>
+        </p:blipFill>
         <p:spPr>
           <a:xfrm>
             <a:off x="7900416" y="2926080"/>
-            <a:ext cx="475488" cy="475488"/>
-          </a:xfrm>
-          <a:prstGeom prst="ellipse">
-            <a:avLst/>
-          </a:prstGeom>
-          <a:solidFill>
-            <a:srgbClr val="FFCF4A"/>
-          </a:solidFill>
-          <a:ln/>
-        </p:spPr>
-      </p:sp>
-      <p:sp>
-        <p:nvSpPr>
-          <p:cNvPr id="18" name="Shape 16"/>
-          <p:cNvSpPr/>
-          <p:nvPr/>
-        </p:nvSpPr>
+            <a:ext cx="512064" cy="512064"/>
+          </a:xfrm>
+          <a:prstGeom prst="rect">
+            <a:avLst/>
+          </a:prstGeom>
+        </p:spPr>
+      </p:pic>
+      <p:pic>
+        <p:nvPicPr>
+          <p:cNvPr id="18" name="Image 8" descr="preencoded.png">    </p:cNvPr>
+          <p:cNvPicPr>
+            <a:picLocks noChangeAspect="1"/>
+          </p:cNvPicPr>
+          <p:nvPr/>
+        </p:nvPicPr>
+        <p:blipFill>
+          <a:blip r:embed="rId9"/>
+          <a:stretch>
+            <a:fillRect/>
+          </a:stretch>
+        </p:blipFill>
         <p:spPr>
           <a:xfrm>
             <a:off x="8558784" y="2926080"/>
-            <a:ext cx="475488" cy="475488"/>
-          </a:xfrm>
-          <a:prstGeom prst="ellipse">
-            <a:avLst/>
-          </a:prstGeom>
-          <a:solidFill>
-            <a:srgbClr val="7FA8D9"/>
-          </a:solidFill>
-          <a:ln/>
-        </p:spPr>
-      </p:sp>
-      <p:sp>
-        <p:nvSpPr>
-          <p:cNvPr id="19" name="Shape 17"/>
-          <p:cNvSpPr/>
-          <p:nvPr/>
-        </p:nvSpPr>
+            <a:ext cx="512064" cy="512064"/>
+          </a:xfrm>
+          <a:prstGeom prst="rect">
+            <a:avLst/>
+          </a:prstGeom>
+        </p:spPr>
+      </p:pic>
+      <p:pic>
+        <p:nvPicPr>
+          <p:cNvPr id="19" name="Image 9" descr="preencoded.png">    </p:cNvPr>
+          <p:cNvPicPr>
+            <a:picLocks noChangeAspect="1"/>
+          </p:cNvPicPr>
+          <p:nvPr/>
+        </p:nvPicPr>
+        <p:blipFill>
+          <a:blip r:embed="rId10"/>
+          <a:stretch>
+            <a:fillRect/>
+          </a:stretch>
+        </p:blipFill>
         <p:spPr>
           <a:xfrm>
             <a:off x="9217152" y="2926080"/>
-            <a:ext cx="475488" cy="475488"/>
-          </a:xfrm>
-          <a:prstGeom prst="ellipse">
-            <a:avLst/>
-          </a:prstGeom>
-          <a:solidFill>
-            <a:srgbClr val="7FA8D9"/>
-          </a:solidFill>
-          <a:ln/>
-        </p:spPr>
-      </p:sp>
-      <p:sp>
-        <p:nvSpPr>
-          <p:cNvPr id="20" name="Text 18"/>
+            <a:ext cx="512064" cy="512064"/>
+          </a:xfrm>
+          <a:prstGeom prst="rect">
+            <a:avLst/>
+          </a:prstGeom>
+        </p:spPr>
+      </p:pic>
+      <p:sp>
+        <p:nvSpPr>
+          <p:cNvPr id="20" name="Text 8"/>
           <p:cNvSpPr/>
           <p:nvPr/>
         </p:nvSpPr>
@@ -9897,7 +10010,7 @@
       </p:sp>
       <p:sp>
         <p:nvSpPr>
-          <p:cNvPr id="21" name="Text 19"/>
+          <p:cNvPr id="21" name="Text 9"/>
           <p:cNvSpPr/>
           <p:nvPr/>
         </p:nvSpPr>
@@ -9931,7 +10044,7 @@
                 <a:ea typeface="Calibri" pitchFamily="34" charset="-122"/>
                 <a:cs typeface="Calibri" pitchFamily="34" charset="-120"/>
               </a:rPr>
-              <a:t>Same two “rainy” days as Ana — but for Ben they are a departure. Change is the signal, not the level.</a:t>
+              <a:t>Same two “not good” days as Ana — but for Ben they are a departure. Change is the signal, not the level.</a:t>
             </a:r>
             <a:endParaRPr lang="en-US" sz="1300" dirty="0"/>
           </a:p>
@@ -9939,7 +10052,7 @@
       </p:sp>
       <p:sp>
         <p:nvSpPr>
-          <p:cNvPr id="22" name="Shape 20"/>
+          <p:cNvPr id="22" name="Shape 10"/>
           <p:cNvSpPr/>
           <p:nvPr/>
         </p:nvSpPr>
@@ -9973,7 +10086,7 @@
       </p:sp>
       <p:sp>
         <p:nvSpPr>
-          <p:cNvPr id="23" name="Text 21"/>
+          <p:cNvPr id="23" name="Text 11"/>
           <p:cNvSpPr/>
           <p:nvPr/>
         </p:nvSpPr>
@@ -10012,7 +10125,7 @@
       </p:sp>
       <p:sp>
         <p:nvSpPr>
-          <p:cNvPr id="24" name="Text 22"/>
+          <p:cNvPr id="24" name="Text 12"/>
           <p:cNvSpPr/>
           <p:nvPr/>
         </p:nvSpPr>

</xml_diff>